<commit_message>
Finalize EduPredict: fix documentation, validate experiments, and update tests
</commit_message>
<xml_diff>
--- a/deliverables/EduPredict_Final_Project_Presentation.pptx
+++ b/deliverables/EduPredict_Final_Project_Presentation.pptx
@@ -796,7 +796,7 @@
           <a:lstStyle/>
           <a:p>
             <a:r>
-              <a:t>Software testing is an essential component of this project. We have 110 automated unit tests passing with a 100% success rate. Our custom AST scanner guarantees that zero third-party ML or numerical libraries exist in the codebase. Furthermore, our solver tests verify that analytical gradients and Normal Equation solutions match down to machine precision.</a:t>
+              <a:t>Software testing is an essential component of this project. We have 117 automated unit tests passing with a 100% success rate (0 skipped, 0 failures, 0 errors). Our custom AST scanner guarantees that zero third-party ML or numerical libraries exist in the codebase. Furthermore, our solver tests verify that analytical gradients and Normal Equation solutions match down to machine precision.</a:t>
             </a:r>
           </a:p>
         </p:txBody>
@@ -6333,7 +6333,7 @@
                         </a:defRPr>
                       </a:pPr>
                       <a:r>
-                        <a:t>Custom KNN Classifier (k=5)</a:t>
+                        <a:t>Custom KNN Classifier (Comparison Baseline, k=5)</a:t>
                       </a:r>
                     </a:p>
                   </a:txBody>
@@ -7066,7 +7066,7 @@
               </a:defRPr>
             </a:pPr>
             <a:r>
-              <a:t>Comprehensive Automated Test Suite (110 Tests):</a:t>
+              <a:t>Comprehensive Automated Test Suite (117 Tests):</a:t>
             </a:r>
           </a:p>
           <a:p>
@@ -7077,7 +7077,7 @@
               <a:defRPr sz="1050"/>
             </a:pPr>
             <a:r>
-              <a:t>• Unittest Framework: Standard library unittest (python -m unittest discover tests) executed in 13.28s with 100% pass rate.</a:t>
+              <a:t>• Unittest Framework: Standard library unittest (python -m unittest discover tests) executed in ~8s with 100% pass rate (0 skipped).</a:t>
             </a:r>
           </a:p>
           <a:p>
@@ -7214,7 +7214,7 @@
               </a:defRPr>
             </a:pPr>
             <a:r>
-              <a:t>✓ Total Test Modules: 15 distinct test files</a:t>
+              <a:t>✓ Total Test Modules: 17 distinct test files</a:t>
             </a:r>
           </a:p>
           <a:p>
@@ -7229,7 +7229,7 @@
               </a:defRPr>
             </a:pPr>
             <a:r>
-              <a:t>✓ Total Test Assertions: 110 automated tests</a:t>
+              <a:t>✓ Total Test Assertions: 117 automated tests (0 skipped)</a:t>
             </a:r>
           </a:p>
           <a:p>
@@ -7685,7 +7685,7 @@
               <a:defRPr sz="1100"/>
             </a:pPr>
             <a:r>
-              <a:t>✓ Zero-Dependency Compliance: Proved that production-quality ML algorithms can be implemented in pure Python with zero external ML libraries.</a:t>
+              <a:t>✓ Zero-Dependency Compliance: Proved that classical machine learning algorithms from first principles can be implemented in pure Python with zero external ML libraries.</a:t>
             </a:r>
           </a:p>
           <a:p>
@@ -7696,7 +7696,7 @@
               <a:defRPr sz="1100"/>
             </a:pPr>
             <a:r>
-              <a:t>✓ Leak-Free Real-World Formulation: Addressed early academic performance and failure risk without circular data leakage.</a:t>
+              <a:t>✓ Leak-Free Experimental Formulation: Addressed early academic performance and failure risk without circular data leakage.</a:t>
             </a:r>
           </a:p>
           <a:p>
@@ -9920,7 +9920,7 @@
             </a:r>
             <a:br/>
             <a:r>
-              <a:t>• Linear Regression: lambda* = 5.0 selected via peak validation R² (+0.0431).</a:t>
+              <a:t>• Linear Regression: lambda* = 5.0 selected via peak validation R² (+0.0423).</a:t>
             </a:r>
             <a:br/>
             <a:r>
@@ -9928,7 +9928,7 @@
             </a:r>
             <a:br/>
             <a:r>
-              <a:t>• KNN: k* = 5 selected for discrimination power (ROC-AUC = 0.5653).</a:t>
+              <a:t>• KNN: k = 5 evaluated as canonical comparison baseline (validation sweep peaks at k = 19, 66.67% accuracy).</a:t>
             </a:r>
           </a:p>
           <a:p>

</xml_diff>